<commit_message>
feat(bible): 2035 pptx 델타 갱신 (2개월치 신기술 반영)
AI_Evolution_Bible_2035.pptx 원본 18 슬라이드 유지 + 2 델타 슬라이드 append (총 20 슬라이드).

Slide 19: 13 organs × 지난 2달 새 사건 (14 row 표):
- ⭐⭐⭐ Memory (Mem0g), Reasoning (Erdős), Agency (ChatGPT Work),
  Evolution (자율 발견) — 4개 최우선
- ⭐⭐ Generation, Perception (Genie 3), Embodiment (Figure 03),
  Simulation (NVIDIA Cosmos) — 4개 중요
- ⭐ Brain, Connectivity, Energy, Trust, Civilization — 5개 참고

Slide 20: 2026-07~08 타임라인 (원본 slide 16 후속):
- 7/24 Claude Opus 5 · 7/1 Fable 5 RESTORED · 7/2 Sonnet 5
- 7/21 Gemini 3.6 · 8/13 Gemini 3.7 Flash
- 8월 OpenAI Sol/Terra/Luna + ChatGPT Work + Erdős 자율 발견
- 4~7월 Mem0g · Zep GraphRAG · Managed Agents streams+webhooks

빌더: docs/update_bible_2035.py (python-pptx · 원본 layout 재사용).
Bible 는 원본 빌더 없어 안전한 append 방식 채택 (기존 슬라이드 무손상).

memory 참조: reference_ai_tech_gap_2026_08.md

Co-Authored-By: Claude Opus 4.7 (1M context) <noreply@anthropic.com>
</commit_message>
<xml_diff>
--- a/docs/AI_Evolution_Bible_2035.pptx
+++ b/docs/AI_Evolution_Bible_2035.pptx
@@ -23,6 +23,8 @@
     <p:sldId id="271" r:id="rId17"/>
     <p:sldId id="272" r:id="rId18"/>
     <p:sldId id="273" r:id="rId19"/>
+    <p:sldId id="274" r:id="rId25"/>
+    <p:sldId id="275" r:id="rId26"/>
   </p:sldIdLst>
   <p:notesMasterIdLst>
     <p:notesMasterId r:id="rId20"/>
@@ -13258,6 +13260,740 @@
 </p:sld>
 </file>
 
+<file path=ppt/slides/slide19.xml><?xml version="1.0" encoding="utf-8"?>
+<p:sld xmlns:a="http://schemas.openxmlformats.org/drawingml/2006/main" xmlns:p="http://schemas.openxmlformats.org/presentationml/2006/main" xmlns:r="http://schemas.openxmlformats.org/officeDocument/2006/relationships">
+  <p:cSld>
+    <p:spTree>
+      <p:nvGrpSpPr>
+        <p:cNvPr id="1" name=""/>
+        <p:cNvGrpSpPr/>
+        <p:nvPr/>
+      </p:nvGrpSpPr>
+      <p:grpSpPr/>
+      <p:sp>
+        <p:nvSpPr>
+          <p:cNvPr id="2" name="TextBox 1"/>
+          <p:cNvSpPr txBox="1"/>
+          <p:nvPr/>
+        </p:nvSpPr>
+        <p:spPr>
+          <a:xfrm>
+            <a:off x="365760" y="274320"/>
+            <a:ext cx="11430000" cy="731520"/>
+          </a:xfrm>
+          <a:prstGeom prst="rect">
+            <a:avLst/>
+          </a:prstGeom>
+          <a:noFill/>
+        </p:spPr>
+        <p:txBody>
+          <a:bodyPr wrap="none">
+            <a:spAutoFit/>
+          </a:bodyPr>
+          <a:lstStyle/>
+          <a:p>
+            <a:pPr>
+              <a:defRPr sz="2800" b="1"/>
+            </a:pPr>
+            <a:r>
+              <a:t>델타 갱신 · 2026-07 이후 7주 새 기술</a:t>
+            </a:r>
+          </a:p>
+        </p:txBody>
+      </p:sp>
+      <p:graphicFrame>
+        <p:nvGraphicFramePr>
+          <p:cNvPr id="3" name="Table 2"/>
+          <p:cNvGraphicFramePr>
+            <a:graphicFrameLocks noGrp="1"/>
+          </p:cNvGraphicFramePr>
+          <p:nvPr/>
+        </p:nvGraphicFramePr>
+        <p:xfrm>
+          <a:off x="365760" y="1097280"/>
+          <a:ext cx="11430000" cy="5303520"/>
+        </p:xfrm>
+        <a:graphic>
+          <a:graphicData uri="http://schemas.openxmlformats.org/drawingml/2006/table">
+            <a:tbl>
+              <a:tblPr firstRow="1" bandRow="1">
+                <a:tableStyleId>{5C22544A-7EE6-4342-B048-85BDC9FD1C3A}</a:tableStyleId>
+              </a:tblPr>
+              <a:tblGrid>
+                <a:gridCol w="2011680"/>
+                <a:gridCol w="914400"/>
+                <a:gridCol w="8503920"/>
+              </a:tblGrid>
+              <a:tr h="378822">
+                <a:tc>
+                  <a:txBody>
+                    <a:bodyPr/>
+                    <a:lstStyle/>
+                    <a:p>
+                      <a:pPr>
+                        <a:defRPr sz="1100" b="1"/>
+                      </a:pPr>
+                      <a:r>
+                        <a:t>Organ (13/13)</a:t>
+                      </a:r>
+                    </a:p>
+                  </a:txBody>
+                  <a:tcPr/>
+                </a:tc>
+                <a:tc>
+                  <a:txBody>
+                    <a:bodyPr/>
+                    <a:lstStyle/>
+                    <a:p>
+                      <a:pPr>
+                        <a:defRPr sz="1100" b="1"/>
+                      </a:pPr>
+                      <a:r>
+                        <a:t>급함</a:t>
+                      </a:r>
+                    </a:p>
+                  </a:txBody>
+                  <a:tcPr/>
+                </a:tc>
+                <a:tc>
+                  <a:txBody>
+                    <a:bodyPr/>
+                    <a:lstStyle/>
+                    <a:p>
+                      <a:pPr>
+                        <a:defRPr sz="1100" b="1"/>
+                      </a:pPr>
+                      <a:r>
+                        <a:t>지난 2달 새 사건</a:t>
+                      </a:r>
+                    </a:p>
+                  </a:txBody>
+                  <a:tcPr/>
+                </a:tc>
+              </a:tr>
+              <a:tr h="378822">
+                <a:tc>
+                  <a:txBody>
+                    <a:bodyPr/>
+                    <a:lstStyle/>
+                    <a:p>
+                      <a:pPr>
+                        <a:defRPr sz="900"/>
+                      </a:pPr>
+                      <a:r>
+                        <a:t>Brain 뇌</a:t>
+                      </a:r>
+                    </a:p>
+                  </a:txBody>
+                  <a:tcPr/>
+                </a:tc>
+                <a:tc>
+                  <a:txBody>
+                    <a:bodyPr/>
+                    <a:lstStyle/>
+                    <a:p>
+                      <a:pPr>
+                        <a:defRPr sz="900"/>
+                      </a:pPr>
+                      <a:r>
+                        <a:t>⭐</a:t>
+                      </a:r>
+                    </a:p>
+                  </a:txBody>
+                  <a:tcPr/>
+                </a:tc>
+                <a:tc>
+                  <a:txBody>
+                    <a:bodyPr/>
+                    <a:lstStyle/>
+                    <a:p>
+                      <a:pPr>
+                        <a:defRPr sz="900"/>
+                      </a:pPr>
+                      <a:r>
+                        <a:t>NVIDIA Rubin CPX · Cerebras Wafer scale 최신</a:t>
+                      </a:r>
+                    </a:p>
+                  </a:txBody>
+                  <a:tcPr/>
+                </a:tc>
+              </a:tr>
+              <a:tr h="378822">
+                <a:tc>
+                  <a:txBody>
+                    <a:bodyPr/>
+                    <a:lstStyle/>
+                    <a:p>
+                      <a:pPr>
+                        <a:defRPr sz="900"/>
+                      </a:pPr>
+                      <a:r>
+                        <a:t>Memory 기억</a:t>
+                      </a:r>
+                    </a:p>
+                  </a:txBody>
+                  <a:tcPr/>
+                </a:tc>
+                <a:tc>
+                  <a:txBody>
+                    <a:bodyPr/>
+                    <a:lstStyle/>
+                    <a:p>
+                      <a:pPr>
+                        <a:defRPr sz="900"/>
+                      </a:pPr>
+                      <a:r>
+                        <a:t>⭐⭐⭐</a:t>
+                      </a:r>
+                    </a:p>
+                  </a:txBody>
+                  <a:tcPr/>
+                </a:tc>
+                <a:tc>
+                  <a:txBody>
+                    <a:bodyPr/>
+                    <a:lstStyle/>
+                    <a:p>
+                      <a:pPr>
+                        <a:defRPr sz="900"/>
+                      </a:pPr>
+                      <a:r>
+                        <a:t>Mem0g graph-enhanced +29.6점 · Zep GraphRAG sub-second</a:t>
+                      </a:r>
+                    </a:p>
+                  </a:txBody>
+                  <a:tcPr/>
+                </a:tc>
+              </a:tr>
+              <a:tr h="378822">
+                <a:tc>
+                  <a:txBody>
+                    <a:bodyPr/>
+                    <a:lstStyle/>
+                    <a:p>
+                      <a:pPr>
+                        <a:defRPr sz="900"/>
+                      </a:pPr>
+                      <a:r>
+                        <a:t>Generation 생성</a:t>
+                      </a:r>
+                    </a:p>
+                  </a:txBody>
+                  <a:tcPr/>
+                </a:tc>
+                <a:tc>
+                  <a:txBody>
+                    <a:bodyPr/>
+                    <a:lstStyle/>
+                    <a:p>
+                      <a:pPr>
+                        <a:defRPr sz="900"/>
+                      </a:pPr>
+                      <a:r>
+                        <a:t>⭐⭐</a:t>
+                      </a:r>
+                    </a:p>
+                  </a:txBody>
+                  <a:tcPr/>
+                </a:tc>
+                <a:tc>
+                  <a:txBody>
+                    <a:bodyPr/>
+                    <a:lstStyle/>
+                    <a:p>
+                      <a:pPr>
+                        <a:defRPr sz="900"/>
+                      </a:pPr>
+                      <a:r>
+                        <a:t>Gemini 3.7 Flash (8/13) · code diffusion · Sora 2 rumor</a:t>
+                      </a:r>
+                    </a:p>
+                  </a:txBody>
+                  <a:tcPr/>
+                </a:tc>
+              </a:tr>
+              <a:tr h="378822">
+                <a:tc>
+                  <a:txBody>
+                    <a:bodyPr/>
+                    <a:lstStyle/>
+                    <a:p>
+                      <a:pPr>
+                        <a:defRPr sz="900"/>
+                      </a:pPr>
+                      <a:r>
+                        <a:t>Connectivity 연결</a:t>
+                      </a:r>
+                    </a:p>
+                  </a:txBody>
+                  <a:tcPr/>
+                </a:tc>
+                <a:tc>
+                  <a:txBody>
+                    <a:bodyPr/>
+                    <a:lstStyle/>
+                    <a:p>
+                      <a:pPr>
+                        <a:defRPr sz="900"/>
+                      </a:pPr>
+                      <a:r>
+                        <a:t>⭐</a:t>
+                      </a:r>
+                    </a:p>
+                  </a:txBody>
+                  <a:tcPr/>
+                </a:tc>
+                <a:tc>
+                  <a:txBody>
+                    <a:bodyPr/>
+                    <a:lstStyle/>
+                    <a:p>
+                      <a:pPr>
+                        <a:defRPr sz="900"/>
+                      </a:pPr>
+                      <a:r>
+                        <a:t>CXL 3.1 · NVLink 6 · Meta MTIA v3</a:t>
+                      </a:r>
+                    </a:p>
+                  </a:txBody>
+                  <a:tcPr/>
+                </a:tc>
+              </a:tr>
+              <a:tr h="378822">
+                <a:tc>
+                  <a:txBody>
+                    <a:bodyPr/>
+                    <a:lstStyle/>
+                    <a:p>
+                      <a:pPr>
+                        <a:defRPr sz="900"/>
+                      </a:pPr>
+                      <a:r>
+                        <a:t>Perception 지각</a:t>
+                      </a:r>
+                    </a:p>
+                  </a:txBody>
+                  <a:tcPr/>
+                </a:tc>
+                <a:tc>
+                  <a:txBody>
+                    <a:bodyPr/>
+                    <a:lstStyle/>
+                    <a:p>
+                      <a:pPr>
+                        <a:defRPr sz="900"/>
+                      </a:pPr>
+                      <a:r>
+                        <a:t>⭐⭐</a:t>
+                      </a:r>
+                    </a:p>
+                  </a:txBody>
+                  <a:tcPr/>
+                </a:tc>
+                <a:tc>
+                  <a:txBody>
+                    <a:bodyPr/>
+                    <a:lstStyle/>
+                    <a:p>
+                      <a:pPr>
+                        <a:defRPr sz="900"/>
+                      </a:pPr>
+                      <a:r>
+                        <a:t>Genie 3 (DeepMind world model, 8월) · 멀티모달 확장</a:t>
+                      </a:r>
+                    </a:p>
+                  </a:txBody>
+                  <a:tcPr/>
+                </a:tc>
+              </a:tr>
+              <a:tr h="378822">
+                <a:tc>
+                  <a:txBody>
+                    <a:bodyPr/>
+                    <a:lstStyle/>
+                    <a:p>
+                      <a:pPr>
+                        <a:defRPr sz="900"/>
+                      </a:pPr>
+                      <a:r>
+                        <a:t>Reasoning 추론</a:t>
+                      </a:r>
+                    </a:p>
+                  </a:txBody>
+                  <a:tcPr/>
+                </a:tc>
+                <a:tc>
+                  <a:txBody>
+                    <a:bodyPr/>
+                    <a:lstStyle/>
+                    <a:p>
+                      <a:pPr>
+                        <a:defRPr sz="900"/>
+                      </a:pPr>
+                      <a:r>
+                        <a:t>⭐⭐⭐</a:t>
+                      </a:r>
+                    </a:p>
+                  </a:txBody>
+                  <a:tcPr/>
+                </a:tc>
+                <a:tc>
+                  <a:txBody>
+                    <a:bodyPr/>
+                    <a:lstStyle/>
+                    <a:p>
+                      <a:pPr>
+                        <a:defRPr sz="900"/>
+                      </a:pPr>
+                      <a:r>
+                        <a:t>OpenAI Erdős 자율 발견 (Fields Medalist 인정) · Gemini 2.5 Deep Think</a:t>
+                      </a:r>
+                    </a:p>
+                  </a:txBody>
+                  <a:tcPr/>
+                </a:tc>
+              </a:tr>
+              <a:tr h="378822">
+                <a:tc>
+                  <a:txBody>
+                    <a:bodyPr/>
+                    <a:lstStyle/>
+                    <a:p>
+                      <a:pPr>
+                        <a:defRPr sz="900"/>
+                      </a:pPr>
+                      <a:r>
+                        <a:t>Energy 에너지</a:t>
+                      </a:r>
+                    </a:p>
+                  </a:txBody>
+                  <a:tcPr/>
+                </a:tc>
+                <a:tc>
+                  <a:txBody>
+                    <a:bodyPr/>
+                    <a:lstStyle/>
+                    <a:p>
+                      <a:pPr>
+                        <a:defRPr sz="900"/>
+                      </a:pPr>
+                      <a:r>
+                        <a:t>⭐</a:t>
+                      </a:r>
+                    </a:p>
+                  </a:txBody>
+                  <a:tcPr/>
+                </a:tc>
+                <a:tc>
+                  <a:txBody>
+                    <a:bodyPr/>
+                    <a:lstStyle/>
+                    <a:p>
+                      <a:pPr>
+                        <a:defRPr sz="900"/>
+                      </a:pPr>
+                      <a:r>
+                        <a:t>Anthropic 소형 원전 · Microsoft Three Mile Island · Google 핵융합</a:t>
+                      </a:r>
+                    </a:p>
+                  </a:txBody>
+                  <a:tcPr/>
+                </a:tc>
+              </a:tr>
+              <a:tr h="378822">
+                <a:tc>
+                  <a:txBody>
+                    <a:bodyPr/>
+                    <a:lstStyle/>
+                    <a:p>
+                      <a:pPr>
+                        <a:defRPr sz="900"/>
+                      </a:pPr>
+                      <a:r>
+                        <a:t>Trust 신뢰</a:t>
+                      </a:r>
+                    </a:p>
+                  </a:txBody>
+                  <a:tcPr/>
+                </a:tc>
+                <a:tc>
+                  <a:txBody>
+                    <a:bodyPr/>
+                    <a:lstStyle/>
+                    <a:p>
+                      <a:pPr>
+                        <a:defRPr sz="900"/>
+                      </a:pPr>
+                      <a:r>
+                        <a:t>⭐</a:t>
+                      </a:r>
+                    </a:p>
+                  </a:txBody>
+                  <a:tcPr/>
+                </a:tc>
+                <a:tc>
+                  <a:txBody>
+                    <a:bodyPr/>
+                    <a:lstStyle/>
+                    <a:p>
+                      <a:pPr>
+                        <a:defRPr sz="900"/>
+                      </a:pPr>
+                      <a:r>
+                        <a:t>Lakera·HiddenLayer 신제품 · Anthropic MechInterp 논문</a:t>
+                      </a:r>
+                    </a:p>
+                  </a:txBody>
+                  <a:tcPr/>
+                </a:tc>
+              </a:tr>
+              <a:tr h="378822">
+                <a:tc>
+                  <a:txBody>
+                    <a:bodyPr/>
+                    <a:lstStyle/>
+                    <a:p>
+                      <a:pPr>
+                        <a:defRPr sz="900"/>
+                      </a:pPr>
+                      <a:r>
+                        <a:t>Agency 행위</a:t>
+                      </a:r>
+                    </a:p>
+                  </a:txBody>
+                  <a:tcPr/>
+                </a:tc>
+                <a:tc>
+                  <a:txBody>
+                    <a:bodyPr/>
+                    <a:lstStyle/>
+                    <a:p>
+                      <a:pPr>
+                        <a:defRPr sz="900"/>
+                      </a:pPr>
+                      <a:r>
+                        <a:t>⭐⭐⭐</a:t>
+                      </a:r>
+                    </a:p>
+                  </a:txBody>
+                  <a:tcPr/>
+                </a:tc>
+                <a:tc>
+                  <a:txBody>
+                    <a:bodyPr/>
+                    <a:lstStyle/>
+                    <a:p>
+                      <a:pPr>
+                        <a:defRPr sz="900"/>
+                      </a:pPr>
+                      <a:r>
+                        <a:t>ChatGPT Work (GPT-5.6) · OpenAI Sol/Terra/Luna tier · Managed Agents · Fable 5 RESTORED</a:t>
+                      </a:r>
+                    </a:p>
+                  </a:txBody>
+                  <a:tcPr/>
+                </a:tc>
+              </a:tr>
+              <a:tr h="378822">
+                <a:tc>
+                  <a:txBody>
+                    <a:bodyPr/>
+                    <a:lstStyle/>
+                    <a:p>
+                      <a:pPr>
+                        <a:defRPr sz="900"/>
+                      </a:pPr>
+                      <a:r>
+                        <a:t>Embodiment 체화</a:t>
+                      </a:r>
+                    </a:p>
+                  </a:txBody>
+                  <a:tcPr/>
+                </a:tc>
+                <a:tc>
+                  <a:txBody>
+                    <a:bodyPr/>
+                    <a:lstStyle/>
+                    <a:p>
+                      <a:pPr>
+                        <a:defRPr sz="900"/>
+                      </a:pPr>
+                      <a:r>
+                        <a:t>⭐⭐</a:t>
+                      </a:r>
+                    </a:p>
+                  </a:txBody>
+                  <a:tcPr/>
+                </a:tc>
+                <a:tc>
+                  <a:txBody>
+                    <a:bodyPr/>
+                    <a:lstStyle/>
+                    <a:p>
+                      <a:pPr>
+                        <a:defRPr sz="900"/>
+                      </a:pPr>
+                      <a:r>
+                        <a:t>Figure 03 · Optimus Gen 3 · Unitree G1 대량생산</a:t>
+                      </a:r>
+                    </a:p>
+                  </a:txBody>
+                  <a:tcPr/>
+                </a:tc>
+              </a:tr>
+              <a:tr h="378822">
+                <a:tc>
+                  <a:txBody>
+                    <a:bodyPr/>
+                    <a:lstStyle/>
+                    <a:p>
+                      <a:pPr>
+                        <a:defRPr sz="900"/>
+                      </a:pPr>
+                      <a:r>
+                        <a:t>Simulation 시뮬</a:t>
+                      </a:r>
+                    </a:p>
+                  </a:txBody>
+                  <a:tcPr/>
+                </a:tc>
+                <a:tc>
+                  <a:txBody>
+                    <a:bodyPr/>
+                    <a:lstStyle/>
+                    <a:p>
+                      <a:pPr>
+                        <a:defRPr sz="900"/>
+                      </a:pPr>
+                      <a:r>
+                        <a:t>⭐⭐</a:t>
+                      </a:r>
+                    </a:p>
+                  </a:txBody>
+                  <a:tcPr/>
+                </a:tc>
+                <a:tc>
+                  <a:txBody>
+                    <a:bodyPr/>
+                    <a:lstStyle/>
+                    <a:p>
+                      <a:pPr>
+                        <a:defRPr sz="900"/>
+                      </a:pPr>
+                      <a:r>
+                        <a:t>NVIDIA Cosmos world foundation · Genie 3 playable worlds</a:t>
+                      </a:r>
+                    </a:p>
+                  </a:txBody>
+                  <a:tcPr/>
+                </a:tc>
+              </a:tr>
+              <a:tr h="378822">
+                <a:tc>
+                  <a:txBody>
+                    <a:bodyPr/>
+                    <a:lstStyle/>
+                    <a:p>
+                      <a:pPr>
+                        <a:defRPr sz="900"/>
+                      </a:pPr>
+                      <a:r>
+                        <a:t>Civilization 문명</a:t>
+                      </a:r>
+                    </a:p>
+                  </a:txBody>
+                  <a:tcPr/>
+                </a:tc>
+                <a:tc>
+                  <a:txBody>
+                    <a:bodyPr/>
+                    <a:lstStyle/>
+                    <a:p>
+                      <a:pPr>
+                        <a:defRPr sz="900"/>
+                      </a:pPr>
+                      <a:r>
+                        <a:t>⭐</a:t>
+                      </a:r>
+                    </a:p>
+                  </a:txBody>
+                  <a:tcPr/>
+                </a:tc>
+                <a:tc>
+                  <a:txBody>
+                    <a:bodyPr/>
+                    <a:lstStyle/>
+                    <a:p>
+                      <a:pPr>
+                        <a:defRPr sz="900"/>
+                      </a:pPr>
+                      <a:r>
+                        <a:t>Managed Agents webhooks (환경·메모리 lifecycle) · agent 경제 논문</a:t>
+                      </a:r>
+                    </a:p>
+                  </a:txBody>
+                  <a:tcPr/>
+                </a:tc>
+              </a:tr>
+              <a:tr h="378834">
+                <a:tc>
+                  <a:txBody>
+                    <a:bodyPr/>
+                    <a:lstStyle/>
+                    <a:p>
+                      <a:pPr>
+                        <a:defRPr sz="900"/>
+                      </a:pPr>
+                      <a:r>
+                        <a:t>Evolution 진화</a:t>
+                      </a:r>
+                    </a:p>
+                  </a:txBody>
+                  <a:tcPr/>
+                </a:tc>
+                <a:tc>
+                  <a:txBody>
+                    <a:bodyPr/>
+                    <a:lstStyle/>
+                    <a:p>
+                      <a:pPr>
+                        <a:defRPr sz="900"/>
+                      </a:pPr>
+                      <a:r>
+                        <a:t>⭐⭐⭐</a:t>
+                      </a:r>
+                    </a:p>
+                  </a:txBody>
+                  <a:tcPr/>
+                </a:tc>
+                <a:tc>
+                  <a:txBody>
+                    <a:bodyPr/>
+                    <a:lstStyle/>
+                    <a:p>
+                      <a:pPr>
+                        <a:defRPr sz="900"/>
+                      </a:pPr>
+                      <a:r>
+                        <a:t>자율 수학 발견 (Erdős) · Claude self-improvement · AlphaEvolve</a:t>
+                      </a:r>
+                    </a:p>
+                  </a:txBody>
+                  <a:tcPr/>
+                </a:tc>
+              </a:tr>
+            </a:tbl>
+          </a:graphicData>
+        </a:graphic>
+      </p:graphicFrame>
+    </p:spTree>
+  </p:cSld>
+  <p:clrMapOvr>
+    <a:masterClrMapping/>
+  </p:clrMapOvr>
+</p:sld>
+</file>
+
 <file path=ppt/slides/slide2.xml><?xml version="1.0" encoding="utf-8"?>
 <p:sld xmlns:a="http://schemas.openxmlformats.org/drawingml/2006/main" xmlns:r="http://schemas.openxmlformats.org/officeDocument/2006/relationships" xmlns:p="http://schemas.openxmlformats.org/presentationml/2006/main">
   <p:cSld name="Slide 2">
@@ -15124,6 +15860,401 @@
           </a:p>
         </p:txBody>
       </p:sp>
+    </p:spTree>
+  </p:cSld>
+  <p:clrMapOvr>
+    <a:masterClrMapping/>
+  </p:clrMapOvr>
+</p:sld>
+</file>
+
+<file path=ppt/slides/slide20.xml><?xml version="1.0" encoding="utf-8"?>
+<p:sld xmlns:a="http://schemas.openxmlformats.org/drawingml/2006/main" xmlns:p="http://schemas.openxmlformats.org/presentationml/2006/main" xmlns:r="http://schemas.openxmlformats.org/officeDocument/2006/relationships">
+  <p:cSld>
+    <p:spTree>
+      <p:nvGrpSpPr>
+        <p:cNvPr id="1" name=""/>
+        <p:cNvGrpSpPr/>
+        <p:nvPr/>
+      </p:nvGrpSpPr>
+      <p:grpSpPr/>
+      <p:sp>
+        <p:nvSpPr>
+          <p:cNvPr id="2" name="TextBox 1"/>
+          <p:cNvSpPr txBox="1"/>
+          <p:nvPr/>
+        </p:nvSpPr>
+        <p:spPr>
+          <a:xfrm>
+            <a:off x="365760" y="274320"/>
+            <a:ext cx="11430000" cy="822960"/>
+          </a:xfrm>
+          <a:prstGeom prst="rect">
+            <a:avLst/>
+          </a:prstGeom>
+          <a:noFill/>
+        </p:spPr>
+        <p:txBody>
+          <a:bodyPr wrap="none">
+            <a:spAutoFit/>
+          </a:bodyPr>
+          <a:lstStyle/>
+          <a:p>
+            <a:pPr>
+              <a:defRPr sz="2400" b="1"/>
+            </a:pPr>
+            <a:r>
+              <a:t>2026-07~08 타임라인 (원본 슬라이드 16 후속)</a:t>
+            </a:r>
+          </a:p>
+        </p:txBody>
+      </p:sp>
+      <p:graphicFrame>
+        <p:nvGraphicFramePr>
+          <p:cNvPr id="3" name="Table 2"/>
+          <p:cNvGraphicFramePr>
+            <a:graphicFrameLocks noGrp="1"/>
+          </p:cNvGraphicFramePr>
+          <p:nvPr/>
+        </p:nvGraphicFramePr>
+        <p:xfrm>
+          <a:off x="457200" y="1280160"/>
+          <a:ext cx="11247120" cy="5120640"/>
+        </p:xfrm>
+        <a:graphic>
+          <a:graphicData uri="http://schemas.openxmlformats.org/drawingml/2006/table">
+            <a:tbl>
+              <a:tblPr firstRow="1" bandRow="1">
+                <a:tableStyleId>{5C22544A-7EE6-4342-B048-85BDC9FD1C3A}</a:tableStyleId>
+              </a:tblPr>
+              <a:tblGrid>
+                <a:gridCol w="1645920"/>
+                <a:gridCol w="9601200"/>
+              </a:tblGrid>
+              <a:tr h="512064">
+                <a:tc>
+                  <a:txBody>
+                    <a:bodyPr/>
+                    <a:lstStyle/>
+                    <a:p>
+                      <a:pPr>
+                        <a:defRPr b="1" sz="1200"/>
+                      </a:pPr>
+                      <a:r>
+                        <a:t>시점</a:t>
+                      </a:r>
+                    </a:p>
+                  </a:txBody>
+                  <a:tcPr/>
+                </a:tc>
+                <a:tc>
+                  <a:txBody>
+                    <a:bodyPr/>
+                    <a:lstStyle/>
+                    <a:p>
+                      <a:pPr>
+                        <a:defRPr b="1" sz="1200"/>
+                      </a:pPr>
+                      <a:r>
+                        <a:t>사건</a:t>
+                      </a:r>
+                    </a:p>
+                  </a:txBody>
+                  <a:tcPr/>
+                </a:tc>
+              </a:tr>
+              <a:tr h="512064">
+                <a:tc>
+                  <a:txBody>
+                    <a:bodyPr/>
+                    <a:lstStyle/>
+                    <a:p>
+                      <a:pPr>
+                        <a:defRPr sz="1100"/>
+                      </a:pPr>
+                      <a:r>
+                        <a:t>2026-07-01</a:t>
+                      </a:r>
+                    </a:p>
+                  </a:txBody>
+                  <a:tcPr/>
+                </a:tc>
+                <a:tc>
+                  <a:txBody>
+                    <a:bodyPr/>
+                    <a:lstStyle/>
+                    <a:p>
+                      <a:pPr>
+                        <a:defRPr sz="1100"/>
+                      </a:pPr>
+                      <a:r>
+                        <a:t>AI Evolution Bible 2035 원본 작성</a:t>
+                      </a:r>
+                    </a:p>
+                  </a:txBody>
+                  <a:tcPr/>
+                </a:tc>
+              </a:tr>
+              <a:tr h="512064">
+                <a:tc>
+                  <a:txBody>
+                    <a:bodyPr/>
+                    <a:lstStyle/>
+                    <a:p>
+                      <a:pPr>
+                        <a:defRPr sz="1100"/>
+                      </a:pPr>
+                      <a:r>
+                        <a:t>2026-07-24</a:t>
+                      </a:r>
+                    </a:p>
+                  </a:txBody>
+                  <a:tcPr/>
+                </a:tc>
+                <a:tc>
+                  <a:txBody>
+                    <a:bodyPr/>
+                    <a:lstStyle/>
+                    <a:p>
+                      <a:pPr>
+                        <a:defRPr sz="1100"/>
+                      </a:pPr>
+                      <a:r>
+                        <a:t>Claude Opus 5 launch — 1M context 기본</a:t>
+                      </a:r>
+                    </a:p>
+                  </a:txBody>
+                  <a:tcPr/>
+                </a:tc>
+              </a:tr>
+              <a:tr h="512064">
+                <a:tc>
+                  <a:txBody>
+                    <a:bodyPr/>
+                    <a:lstStyle/>
+                    <a:p>
+                      <a:pPr>
+                        <a:defRPr sz="1100"/>
+                      </a:pPr>
+                      <a:r>
+                        <a:t>2026-07-01</a:t>
+                      </a:r>
+                    </a:p>
+                  </a:txBody>
+                  <a:tcPr/>
+                </a:tc>
+                <a:tc>
+                  <a:txBody>
+                    <a:bodyPr/>
+                    <a:lstStyle/>
+                    <a:p>
+                      <a:pPr>
+                        <a:defRPr sz="1100"/>
+                      </a:pPr>
+                      <a:r>
+                        <a:t>Anthropic Fable 5 RESTORED (US export-control 6/12 → 7/1 복원)</a:t>
+                      </a:r>
+                    </a:p>
+                  </a:txBody>
+                  <a:tcPr/>
+                </a:tc>
+              </a:tr>
+              <a:tr h="512064">
+                <a:tc>
+                  <a:txBody>
+                    <a:bodyPr/>
+                    <a:lstStyle/>
+                    <a:p>
+                      <a:pPr>
+                        <a:defRPr sz="1100"/>
+                      </a:pPr>
+                      <a:r>
+                        <a:t>2026-07-02</a:t>
+                      </a:r>
+                    </a:p>
+                  </a:txBody>
+                  <a:tcPr/>
+                </a:tc>
+                <a:tc>
+                  <a:txBody>
+                    <a:bodyPr/>
+                    <a:lstStyle/>
+                    <a:p>
+                      <a:pPr>
+                        <a:defRPr sz="1100"/>
+                      </a:pPr>
+                      <a:r>
+                        <a:t>Claude Sonnet 5 launch · 이후 8/10 $2/$10 확정</a:t>
+                      </a:r>
+                    </a:p>
+                  </a:txBody>
+                  <a:tcPr/>
+                </a:tc>
+              </a:tr>
+              <a:tr h="512064">
+                <a:tc>
+                  <a:txBody>
+                    <a:bodyPr/>
+                    <a:lstStyle/>
+                    <a:p>
+                      <a:pPr>
+                        <a:defRPr sz="1100"/>
+                      </a:pPr>
+                      <a:r>
+                        <a:t>2026-07-21</a:t>
+                      </a:r>
+                    </a:p>
+                  </a:txBody>
+                  <a:tcPr/>
+                </a:tc>
+                <a:tc>
+                  <a:txBody>
+                    <a:bodyPr/>
+                    <a:lstStyle/>
+                    <a:p>
+                      <a:pPr>
+                        <a:defRPr sz="1100"/>
+                      </a:pPr>
+                      <a:r>
+                        <a:t>Gemini 3.6 Flash · 8/13 Gemini 3.7 Flash</a:t>
+                      </a:r>
+                    </a:p>
+                  </a:txBody>
+                  <a:tcPr/>
+                </a:tc>
+              </a:tr>
+              <a:tr h="512064">
+                <a:tc>
+                  <a:txBody>
+                    <a:bodyPr/>
+                    <a:lstStyle/>
+                    <a:p>
+                      <a:pPr>
+                        <a:defRPr sz="1100"/>
+                      </a:pPr>
+                      <a:r>
+                        <a:t>2026-08 초</a:t>
+                      </a:r>
+                    </a:p>
+                  </a:txBody>
+                  <a:tcPr/>
+                </a:tc>
+                <a:tc>
+                  <a:txBody>
+                    <a:bodyPr/>
+                    <a:lstStyle/>
+                    <a:p>
+                      <a:pPr>
+                        <a:defRPr sz="1100"/>
+                      </a:pPr>
+                      <a:r>
+                        <a:t>OpenAI Sol/Terra/Luna tier 재편 · ChatGPT Work</a:t>
+                      </a:r>
+                    </a:p>
+                  </a:txBody>
+                  <a:tcPr/>
+                </a:tc>
+              </a:tr>
+              <a:tr h="512064">
+                <a:tc>
+                  <a:txBody>
+                    <a:bodyPr/>
+                    <a:lstStyle/>
+                    <a:p>
+                      <a:pPr>
+                        <a:defRPr sz="1100"/>
+                      </a:pPr>
+                      <a:r>
+                        <a:t>2026-08</a:t>
+                      </a:r>
+                    </a:p>
+                  </a:txBody>
+                  <a:tcPr/>
+                </a:tc>
+                <a:tc>
+                  <a:txBody>
+                    <a:bodyPr/>
+                    <a:lstStyle/>
+                    <a:p>
+                      <a:pPr>
+                        <a:defRPr sz="1100"/>
+                      </a:pPr>
+                      <a:r>
+                        <a:t>OpenAI reasoning 자율 수학 발견 (Erdős) — Fields Medalist 인정</a:t>
+                      </a:r>
+                    </a:p>
+                  </a:txBody>
+                  <a:tcPr/>
+                </a:tc>
+              </a:tr>
+              <a:tr h="512064">
+                <a:tc>
+                  <a:txBody>
+                    <a:bodyPr/>
+                    <a:lstStyle/>
+                    <a:p>
+                      <a:pPr>
+                        <a:defRPr sz="1100"/>
+                      </a:pPr>
+                      <a:r>
+                        <a:t>2026-04~06</a:t>
+                      </a:r>
+                    </a:p>
+                  </a:txBody>
+                  <a:tcPr/>
+                </a:tc>
+                <a:tc>
+                  <a:txBody>
+                    <a:bodyPr/>
+                    <a:lstStyle/>
+                    <a:p>
+                      <a:pPr>
+                        <a:defRPr sz="1100"/>
+                      </a:pPr>
+                      <a:r>
+                        <a:t>Mem0g graph-enhanced (temporal +29.6점)</a:t>
+                      </a:r>
+                    </a:p>
+                  </a:txBody>
+                  <a:tcPr/>
+                </a:tc>
+              </a:tr>
+              <a:tr h="512064">
+                <a:tc>
+                  <a:txBody>
+                    <a:bodyPr/>
+                    <a:lstStyle/>
+                    <a:p>
+                      <a:pPr>
+                        <a:defRPr sz="1100"/>
+                      </a:pPr>
+                      <a:r>
+                        <a:t>2026-06~07</a:t>
+                      </a:r>
+                    </a:p>
+                  </a:txBody>
+                  <a:tcPr/>
+                </a:tc>
+                <a:tc>
+                  <a:txBody>
+                    <a:bodyPr/>
+                    <a:lstStyle/>
+                    <a:p>
+                      <a:pPr>
+                        <a:defRPr sz="1100"/>
+                      </a:pPr>
+                      <a:r>
+                        <a:t>Zep GraphRAG · Managed Agents session streams+webhooks</a:t>
+                      </a:r>
+                    </a:p>
+                  </a:txBody>
+                  <a:tcPr/>
+                </a:tc>
+              </a:tr>
+            </a:tbl>
+          </a:graphicData>
+        </a:graphic>
+      </p:graphicFrame>
     </p:spTree>
   </p:cSld>
   <p:clrMapOvr>

</xml_diff>